<commit_message>
Update docs: add all 4 student names to report and presentation
</commit_message>
<xml_diff>
--- a/docs/presentation_akri.pptx
+++ b/docs/presentation_akri.pptx
@@ -2108,7 +2108,7 @@
                 <a:ea typeface="Calibri" pitchFamily="34" charset="-122"/>
                 <a:cs typeface="Calibri" pitchFamily="34" charset="-120"/>
               </a:rPr>
-              <a:t>Hamdi Islem  |  M1 Génie Logiciel  |  Université de Boumerdès</a:t>
+              <a:t>Hamdi Mohamed Islem  ·  Aya Ghernout  ·  Meriem Foudi  ·  Sidi Yasmine  |  M1 GL — Université de Boumerdès</a:t>
             </a:r>
             <a:endParaRPr lang="en-US" sz="1200" dirty="0"/>
           </a:p>
@@ -4356,7 +4356,7 @@
                 <a:ea typeface="Calibri" pitchFamily="34" charset="-122"/>
                 <a:cs typeface="Calibri" pitchFamily="34" charset="-120"/>
               </a:rPr>
-              <a:t>Akri.dz — Location de voitures en Algérie  |  AOS 2024-2025  |  Hamdi Islem</a:t>
+              <a:t>Akri.dz — Location de voitures en Algérie  |  AOS 2024-2025  |  Hamdi Mohamed Islem · Aya Ghernout · Meriem Foudi · Sidi Yasmine</a:t>
             </a:r>
             <a:endParaRPr lang="en-US" sz="1300" dirty="0"/>
           </a:p>

</xml_diff>